<commit_message>
permutations for selecting components
</commit_message>
<xml_diff>
--- a/01R/99_slides_with_code.pptx
+++ b/01R/99_slides_with_code.pptx
@@ -3185,7 +3185,7 @@
             </a:pPr>
             <a:r>
               <a:rPr/>
-              <a:t>2025-06-01</a:t>
+              <a:t>2025-06-03</a:t>
             </a:r>
           </a:p>
         </p:txBody>
@@ -5916,7 +5916,160 @@
                 </a:solidFill>
                 <a:latin typeface="Courier"/>
               </a:rPr>
-              <a:t> M)</a:t>
+              <a:t> M, </a:t>
+            </a:r>
+            <a:r>
+              <a:rPr>
+                <a:solidFill>
+                  <a:srgbClr val="657422"/>
+                </a:solidFill>
+                <a:latin typeface="Courier"/>
+              </a:rPr>
+              <a:t>color =</a:t>
+            </a:r>
+            <a:r>
+              <a:rPr>
+                <a:solidFill>
+                  <a:srgbClr val="003B4F"/>
+                </a:solidFill>
+                <a:latin typeface="Courier"/>
+              </a:rPr>
+              <a:t> </a:t>
+            </a:r>
+            <a:r>
+              <a:rPr>
+                <a:solidFill>
+                  <a:srgbClr val="AD0000"/>
+                </a:solidFill>
+                <a:latin typeface="Courier"/>
+              </a:rPr>
+              <a:t>1</a:t>
+            </a:r>
+            <a:r>
+              <a:rPr>
+                <a:solidFill>
+                  <a:srgbClr val="5E5E5E"/>
+                </a:solidFill>
+                <a:latin typeface="Courier"/>
+              </a:rPr>
+              <a:t>:</a:t>
+            </a:r>
+            <a:r>
+              <a:rPr>
+                <a:solidFill>
+                  <a:srgbClr val="AD0000"/>
+                </a:solidFill>
+                <a:latin typeface="Courier"/>
+              </a:rPr>
+              <a:t>3</a:t>
+            </a:r>
+            <a:r>
+              <a:rPr>
+                <a:solidFill>
+                  <a:srgbClr val="003B4F"/>
+                </a:solidFill>
+                <a:latin typeface="Courier"/>
+              </a:rPr>
+              <a:t>, </a:t>
+            </a:r>
+            <a:r>
+              <a:rPr>
+                <a:solidFill>
+                  <a:srgbClr val="657422"/>
+                </a:solidFill>
+                <a:latin typeface="Courier"/>
+              </a:rPr>
+              <a:t>legend_breaks =</a:t>
+            </a:r>
+            <a:r>
+              <a:rPr>
+                <a:solidFill>
+                  <a:srgbClr val="003B4F"/>
+                </a:solidFill>
+                <a:latin typeface="Courier"/>
+              </a:rPr>
+              <a:t> </a:t>
+            </a:r>
+            <a:r>
+              <a:rPr>
+                <a:solidFill>
+                  <a:srgbClr val="4758AB"/>
+                </a:solidFill>
+                <a:latin typeface="Courier"/>
+              </a:rPr>
+              <a:t>c</a:t>
+            </a:r>
+            <a:r>
+              <a:rPr>
+                <a:solidFill>
+                  <a:srgbClr val="003B4F"/>
+                </a:solidFill>
+                <a:latin typeface="Courier"/>
+              </a:rPr>
+              <a:t>(</a:t>
+            </a:r>
+            <a:r>
+              <a:rPr>
+                <a:solidFill>
+                  <a:srgbClr val="5E5E5E"/>
+                </a:solidFill>
+                <a:latin typeface="Courier"/>
+              </a:rPr>
+              <a:t>-</a:t>
+            </a:r>
+            <a:r>
+              <a:rPr>
+                <a:solidFill>
+                  <a:srgbClr val="AD0000"/>
+                </a:solidFill>
+                <a:latin typeface="Courier"/>
+              </a:rPr>
+              <a:t>2</a:t>
+            </a:r>
+            <a:r>
+              <a:rPr>
+                <a:solidFill>
+                  <a:srgbClr val="003B4F"/>
+                </a:solidFill>
+                <a:latin typeface="Courier"/>
+              </a:rPr>
+              <a:t>, </a:t>
+            </a:r>
+            <a:r>
+              <a:rPr>
+                <a:solidFill>
+                  <a:srgbClr val="AD0000"/>
+                </a:solidFill>
+                <a:latin typeface="Courier"/>
+              </a:rPr>
+              <a:t>0</a:t>
+            </a:r>
+            <a:r>
+              <a:rPr>
+                <a:solidFill>
+                  <a:srgbClr val="003B4F"/>
+                </a:solidFill>
+                <a:latin typeface="Courier"/>
+              </a:rPr>
+              <a:t>, </a:t>
+            </a:r>
+            <a:r>
+              <a:rPr>
+                <a:solidFill>
+                  <a:srgbClr val="AD0000"/>
+                </a:solidFill>
+                <a:latin typeface="Courier"/>
+              </a:rPr>
+              <a:t>2</a:t>
+            </a:r>
+            <a:r>
+              <a:rPr>
+                <a:solidFill>
+                  <a:srgbClr val="003B4F"/>
+                </a:solidFill>
+                <a:latin typeface="Courier"/>
+              </a:rPr>
+              <a:t>))</a:t>
             </a:r>
           </a:p>
         </p:txBody>

</xml_diff>